<commit_message>
Update Presentación Trabajo Final Tesis Profesional Moderna Sencilla Azul .pptx
</commit_message>
<xml_diff>
--- a/redaccion/defensa/Presentación Trabajo Final Tesis Profesional Moderna Sencilla Azul .pptx
+++ b/redaccion/defensa/Presentación Trabajo Final Tesis Profesional Moderna Sencilla Azul .pptx
@@ -254,7 +254,7 @@
           <a:p>
             <a:fld id="{512FB25D-F884-468F-A70A-BA48D5C74FC7}" type="datetimeFigureOut">
               <a:rPr lang="es-ES" smtClean="0"/>
-              <a:t>24/06/2026</a:t>
+              <a:t>25/06/2026</a:t>
             </a:fld>
             <a:endParaRPr lang="es-ES"/>
           </a:p>
@@ -412,7 +412,7 @@
           <a:p>
             <a:fld id="{A668A2CB-74A5-4546-B53C-5D8DBB6BE761}" type="slidenum">
               <a:rPr lang="es-ES" smtClean="0"/>
-              <a:t>‹Nº›</a:t>
+              <a:t>‹#›</a:t>
             </a:fld>
             <a:endParaRPr lang="es-ES"/>
           </a:p>
@@ -624,7 +624,7 @@
       </p:grpSpPr>
       <p:sp>
         <p:nvSpPr>
-          <p:cNvPr id="2" name="Marcador de imagen de diapositiva 1"/>
+          <p:cNvPr id="2" name="Slide Image Placeholder 1"/>
           <p:cNvSpPr>
             <a:spLocks noGrp="1" noRot="1" noChangeAspect="1"/>
           </p:cNvSpPr>
@@ -636,7 +636,7 @@
       </p:sp>
       <p:sp>
         <p:nvSpPr>
-          <p:cNvPr id="3" name="Marcador de notas 2"/>
+          <p:cNvPr id="3" name="Notes Placeholder 2"/>
           <p:cNvSpPr>
             <a:spLocks noGrp="1"/>
           </p:cNvSpPr>
@@ -655,7 +655,7 @@
       </p:sp>
       <p:sp>
         <p:nvSpPr>
-          <p:cNvPr id="4" name="Marcador de número de diapositiva 3"/>
+          <p:cNvPr id="4" name="Slide Number Placeholder 3"/>
           <p:cNvSpPr>
             <a:spLocks noGrp="1"/>
           </p:cNvSpPr>
@@ -670,7 +670,7 @@
           <a:p>
             <a:fld id="{A668A2CB-74A5-4546-B53C-5D8DBB6BE761}" type="slidenum">
               <a:rPr lang="es-ES" smtClean="0"/>
-              <a:t>7</a:t>
+              <a:t>5</a:t>
             </a:fld>
             <a:endParaRPr lang="es-ES"/>
           </a:p>
@@ -679,7 +679,7 @@
     </p:spTree>
     <p:extLst>
       <p:ext uri="{BB962C8B-B14F-4D97-AF65-F5344CB8AC3E}">
-        <p14:creationId xmlns:p14="http://schemas.microsoft.com/office/powerpoint/2010/main" val="180650169"/>
+        <p14:creationId xmlns:p14="http://schemas.microsoft.com/office/powerpoint/2010/main" val="3957622291"/>
       </p:ext>
     </p:extLst>
   </p:cSld>
@@ -754,6 +754,90 @@
           <a:p>
             <a:fld id="{A668A2CB-74A5-4546-B53C-5D8DBB6BE761}" type="slidenum">
               <a:rPr lang="es-ES" smtClean="0"/>
+              <a:t>7</a:t>
+            </a:fld>
+            <a:endParaRPr lang="es-ES"/>
+          </a:p>
+        </p:txBody>
+      </p:sp>
+    </p:spTree>
+    <p:extLst>
+      <p:ext uri="{BB962C8B-B14F-4D97-AF65-F5344CB8AC3E}">
+        <p14:creationId xmlns:p14="http://schemas.microsoft.com/office/powerpoint/2010/main" val="180650169"/>
+      </p:ext>
+    </p:extLst>
+  </p:cSld>
+  <p:clrMapOvr>
+    <a:masterClrMapping/>
+  </p:clrMapOvr>
+</p:notes>
+</file>
+
+<file path=ppt/notesSlides/notesSlide4.xml><?xml version="1.0" encoding="utf-8"?>
+<p:notes xmlns:a="http://schemas.openxmlformats.org/drawingml/2006/main" xmlns:r="http://schemas.openxmlformats.org/officeDocument/2006/relationships" xmlns:p="http://schemas.openxmlformats.org/presentationml/2006/main">
+  <p:cSld>
+    <p:spTree>
+      <p:nvGrpSpPr>
+        <p:cNvPr id="1" name=""/>
+        <p:cNvGrpSpPr/>
+        <p:nvPr/>
+      </p:nvGrpSpPr>
+      <p:grpSpPr>
+        <a:xfrm>
+          <a:off x="0" y="0"/>
+          <a:ext cx="0" cy="0"/>
+          <a:chOff x="0" y="0"/>
+          <a:chExt cx="0" cy="0"/>
+        </a:xfrm>
+      </p:grpSpPr>
+      <p:sp>
+        <p:nvSpPr>
+          <p:cNvPr id="2" name="Marcador de imagen de diapositiva 1"/>
+          <p:cNvSpPr>
+            <a:spLocks noGrp="1" noRot="1" noChangeAspect="1"/>
+          </p:cNvSpPr>
+          <p:nvPr>
+            <p:ph type="sldImg"/>
+          </p:nvPr>
+        </p:nvSpPr>
+        <p:spPr/>
+      </p:sp>
+      <p:sp>
+        <p:nvSpPr>
+          <p:cNvPr id="3" name="Marcador de notas 2"/>
+          <p:cNvSpPr>
+            <a:spLocks noGrp="1"/>
+          </p:cNvSpPr>
+          <p:nvPr>
+            <p:ph type="body" idx="1"/>
+          </p:nvPr>
+        </p:nvSpPr>
+        <p:spPr/>
+        <p:txBody>
+          <a:bodyPr/>
+          <a:lstStyle/>
+          <a:p>
+            <a:endParaRPr lang="es-ES" dirty="0"/>
+          </a:p>
+        </p:txBody>
+      </p:sp>
+      <p:sp>
+        <p:nvSpPr>
+          <p:cNvPr id="4" name="Marcador de número de diapositiva 3"/>
+          <p:cNvSpPr>
+            <a:spLocks noGrp="1"/>
+          </p:cNvSpPr>
+          <p:nvPr>
+            <p:ph type="sldNum" sz="quarter" idx="5"/>
+          </p:nvPr>
+        </p:nvSpPr>
+        <p:spPr/>
+        <p:txBody>
+          <a:bodyPr/>
+          <a:lstStyle/>
+          <a:p>
+            <a:fld id="{A668A2CB-74A5-4546-B53C-5D8DBB6BE761}" type="slidenum">
+              <a:rPr lang="es-ES" smtClean="0"/>
               <a:t>8</a:t>
             </a:fld>
             <a:endParaRPr lang="es-ES"/>
@@ -773,7 +857,7 @@
 </p:notes>
 </file>
 
-<file path=ppt/notesSlides/notesSlide4.xml><?xml version="1.0" encoding="utf-8"?>
+<file path=ppt/notesSlides/notesSlide5.xml><?xml version="1.0" encoding="utf-8"?>
 <p:notes xmlns:a="http://schemas.openxmlformats.org/drawingml/2006/main" xmlns:r="http://schemas.openxmlformats.org/officeDocument/2006/relationships" xmlns:p="http://schemas.openxmlformats.org/presentationml/2006/main">
   <p:cSld>
     <p:spTree>
@@ -1061,7 +1145,7 @@
             <a:fld id="{1D8BD707-D9CF-40AE-B4C6-C98DA3205C09}" type="datetimeFigureOut">
               <a:rPr lang="en-US" smtClean="0"/>
               <a:pPr/>
-              <a:t>6/24/2026</a:t>
+              <a:t>6/25/2026</a:t>
             </a:fld>
             <a:endParaRPr lang="en-US"/>
           </a:p>
@@ -1104,7 +1188,7 @@
             <a:fld id="{B6F15528-21DE-4FAA-801E-634DDDAF4B2B}" type="slidenum">
               <a:rPr lang="en-US" smtClean="0"/>
               <a:pPr/>
-              <a:t>‹Nº›</a:t>
+              <a:t>‹#›</a:t>
             </a:fld>
             <a:endParaRPr lang="en-US"/>
           </a:p>
@@ -1226,7 +1310,7 @@
             <a:fld id="{1D8BD707-D9CF-40AE-B4C6-C98DA3205C09}" type="datetimeFigureOut">
               <a:rPr lang="en-US" smtClean="0"/>
               <a:pPr/>
-              <a:t>6/24/2026</a:t>
+              <a:t>6/25/2026</a:t>
             </a:fld>
             <a:endParaRPr lang="en-US"/>
           </a:p>
@@ -1269,7 +1353,7 @@
             <a:fld id="{B6F15528-21DE-4FAA-801E-634DDDAF4B2B}" type="slidenum">
               <a:rPr lang="en-US" smtClean="0"/>
               <a:pPr/>
-              <a:t>‹Nº›</a:t>
+              <a:t>‹#›</a:t>
             </a:fld>
             <a:endParaRPr lang="en-US"/>
           </a:p>
@@ -1401,7 +1485,7 @@
             <a:fld id="{1D8BD707-D9CF-40AE-B4C6-C98DA3205C09}" type="datetimeFigureOut">
               <a:rPr lang="en-US" smtClean="0"/>
               <a:pPr/>
-              <a:t>6/24/2026</a:t>
+              <a:t>6/25/2026</a:t>
             </a:fld>
             <a:endParaRPr lang="en-US"/>
           </a:p>
@@ -1444,7 +1528,7 @@
             <a:fld id="{B6F15528-21DE-4FAA-801E-634DDDAF4B2B}" type="slidenum">
               <a:rPr lang="en-US" smtClean="0"/>
               <a:pPr/>
-              <a:t>‹Nº›</a:t>
+              <a:t>‹#›</a:t>
             </a:fld>
             <a:endParaRPr lang="en-US"/>
           </a:p>
@@ -1566,7 +1650,7 @@
             <a:fld id="{1D8BD707-D9CF-40AE-B4C6-C98DA3205C09}" type="datetimeFigureOut">
               <a:rPr lang="en-US" smtClean="0"/>
               <a:pPr/>
-              <a:t>6/24/2026</a:t>
+              <a:t>6/25/2026</a:t>
             </a:fld>
             <a:endParaRPr lang="en-US"/>
           </a:p>
@@ -1609,7 +1693,7 @@
             <a:fld id="{B6F15528-21DE-4FAA-801E-634DDDAF4B2B}" type="slidenum">
               <a:rPr lang="en-US" smtClean="0"/>
               <a:pPr/>
-              <a:t>‹Nº›</a:t>
+              <a:t>‹#›</a:t>
             </a:fld>
             <a:endParaRPr lang="en-US"/>
           </a:p>
@@ -1808,7 +1892,7 @@
             <a:fld id="{1D8BD707-D9CF-40AE-B4C6-C98DA3205C09}" type="datetimeFigureOut">
               <a:rPr lang="en-US" smtClean="0"/>
               <a:pPr/>
-              <a:t>6/24/2026</a:t>
+              <a:t>6/25/2026</a:t>
             </a:fld>
             <a:endParaRPr lang="en-US"/>
           </a:p>
@@ -1851,7 +1935,7 @@
             <a:fld id="{B6F15528-21DE-4FAA-801E-634DDDAF4B2B}" type="slidenum">
               <a:rPr lang="en-US" smtClean="0"/>
               <a:pPr/>
-              <a:t>‹Nº›</a:t>
+              <a:t>‹#›</a:t>
             </a:fld>
             <a:endParaRPr lang="en-US"/>
           </a:p>
@@ -2090,7 +2174,7 @@
             <a:fld id="{1D8BD707-D9CF-40AE-B4C6-C98DA3205C09}" type="datetimeFigureOut">
               <a:rPr lang="en-US" smtClean="0"/>
               <a:pPr/>
-              <a:t>6/24/2026</a:t>
+              <a:t>6/25/2026</a:t>
             </a:fld>
             <a:endParaRPr lang="en-US"/>
           </a:p>
@@ -2133,7 +2217,7 @@
             <a:fld id="{B6F15528-21DE-4FAA-801E-634DDDAF4B2B}" type="slidenum">
               <a:rPr lang="en-US" smtClean="0"/>
               <a:pPr/>
-              <a:t>‹Nº›</a:t>
+              <a:t>‹#›</a:t>
             </a:fld>
             <a:endParaRPr lang="en-US"/>
           </a:p>
@@ -2506,7 +2590,7 @@
             <a:fld id="{1D8BD707-D9CF-40AE-B4C6-C98DA3205C09}" type="datetimeFigureOut">
               <a:rPr lang="en-US" smtClean="0"/>
               <a:pPr/>
-              <a:t>6/24/2026</a:t>
+              <a:t>6/25/2026</a:t>
             </a:fld>
             <a:endParaRPr lang="en-US"/>
           </a:p>
@@ -2549,7 +2633,7 @@
             <a:fld id="{B6F15528-21DE-4FAA-801E-634DDDAF4B2B}" type="slidenum">
               <a:rPr lang="en-US" smtClean="0"/>
               <a:pPr/>
-              <a:t>‹Nº›</a:t>
+              <a:t>‹#›</a:t>
             </a:fld>
             <a:endParaRPr lang="en-US"/>
           </a:p>
@@ -2620,7 +2704,7 @@
             <a:fld id="{1D8BD707-D9CF-40AE-B4C6-C98DA3205C09}" type="datetimeFigureOut">
               <a:rPr lang="en-US" smtClean="0"/>
               <a:pPr/>
-              <a:t>6/24/2026</a:t>
+              <a:t>6/25/2026</a:t>
             </a:fld>
             <a:endParaRPr lang="en-US"/>
           </a:p>
@@ -2663,7 +2747,7 @@
             <a:fld id="{B6F15528-21DE-4FAA-801E-634DDDAF4B2B}" type="slidenum">
               <a:rPr lang="en-US" smtClean="0"/>
               <a:pPr/>
-              <a:t>‹Nº›</a:t>
+              <a:t>‹#›</a:t>
             </a:fld>
             <a:endParaRPr lang="en-US"/>
           </a:p>
@@ -2712,7 +2796,7 @@
             <a:fld id="{1D8BD707-D9CF-40AE-B4C6-C98DA3205C09}" type="datetimeFigureOut">
               <a:rPr lang="en-US" smtClean="0"/>
               <a:pPr/>
-              <a:t>6/24/2026</a:t>
+              <a:t>6/25/2026</a:t>
             </a:fld>
             <a:endParaRPr lang="en-US"/>
           </a:p>
@@ -2755,7 +2839,7 @@
             <a:fld id="{B6F15528-21DE-4FAA-801E-634DDDAF4B2B}" type="slidenum">
               <a:rPr lang="en-US" smtClean="0"/>
               <a:pPr/>
-              <a:t>‹Nº›</a:t>
+              <a:t>‹#›</a:t>
             </a:fld>
             <a:endParaRPr lang="en-US"/>
           </a:p>
@@ -2984,7 +3068,7 @@
             <a:fld id="{1D8BD707-D9CF-40AE-B4C6-C98DA3205C09}" type="datetimeFigureOut">
               <a:rPr lang="en-US" smtClean="0"/>
               <a:pPr/>
-              <a:t>6/24/2026</a:t>
+              <a:t>6/25/2026</a:t>
             </a:fld>
             <a:endParaRPr lang="en-US"/>
           </a:p>
@@ -3027,7 +3111,7 @@
             <a:fld id="{B6F15528-21DE-4FAA-801E-634DDDAF4B2B}" type="slidenum">
               <a:rPr lang="en-US" smtClean="0"/>
               <a:pPr/>
-              <a:t>‹Nº›</a:t>
+              <a:t>‹#›</a:t>
             </a:fld>
             <a:endParaRPr lang="en-US"/>
           </a:p>
@@ -3233,7 +3317,7 @@
             <a:fld id="{1D8BD707-D9CF-40AE-B4C6-C98DA3205C09}" type="datetimeFigureOut">
               <a:rPr lang="en-US" smtClean="0"/>
               <a:pPr/>
-              <a:t>6/24/2026</a:t>
+              <a:t>6/25/2026</a:t>
             </a:fld>
             <a:endParaRPr lang="en-US"/>
           </a:p>
@@ -3276,7 +3360,7 @@
             <a:fld id="{B6F15528-21DE-4FAA-801E-634DDDAF4B2B}" type="slidenum">
               <a:rPr lang="en-US" smtClean="0"/>
               <a:pPr/>
-              <a:t>‹Nº›</a:t>
+              <a:t>‹#›</a:t>
             </a:fld>
             <a:endParaRPr lang="en-US"/>
           </a:p>
@@ -3441,7 +3525,7 @@
             <a:fld id="{1D8BD707-D9CF-40AE-B4C6-C98DA3205C09}" type="datetimeFigureOut">
               <a:rPr lang="en-US" smtClean="0"/>
               <a:pPr/>
-              <a:t>6/24/2026</a:t>
+              <a:t>6/25/2026</a:t>
             </a:fld>
             <a:endParaRPr lang="en-US"/>
           </a:p>
@@ -3520,7 +3604,7 @@
             <a:fld id="{B6F15528-21DE-4FAA-801E-634DDDAF4B2B}" type="slidenum">
               <a:rPr lang="en-US" smtClean="0"/>
               <a:pPr/>
-              <a:t>‹Nº›</a:t>
+              <a:t>‹#›</a:t>
             </a:fld>
             <a:endParaRPr lang="en-US"/>
           </a:p>
@@ -5748,43 +5832,6 @@
       </p:sp>
       <p:sp>
         <p:nvSpPr>
-          <p:cNvPr id="9" name="AutoShape 9">
-            <a:extLst>
-              <a:ext uri="{FF2B5EF4-FFF2-40B4-BE49-F238E27FC236}">
-                <a16:creationId xmlns:a16="http://schemas.microsoft.com/office/drawing/2014/main" id="{A0788983-AEC4-2773-5C26-07BDC25F59C0}"/>
-              </a:ext>
-            </a:extLst>
-          </p:cNvPr>
-          <p:cNvSpPr/>
-          <p:nvPr/>
-        </p:nvSpPr>
-        <p:spPr>
-          <a:xfrm>
-            <a:off x="9372600" y="1485900"/>
-            <a:ext cx="7886700" cy="45975"/>
-          </a:xfrm>
-          <a:prstGeom prst="line">
-            <a:avLst/>
-          </a:prstGeom>
-          <a:ln w="38100" cap="flat">
-            <a:solidFill>
-              <a:srgbClr val="FFFFFF"/>
-            </a:solidFill>
-            <a:prstDash val="solid"/>
-            <a:headEnd type="none" w="sm" len="sm"/>
-            <a:tailEnd type="none" w="sm" len="sm"/>
-          </a:ln>
-        </p:spPr>
-        <p:txBody>
-          <a:bodyPr/>
-          <a:lstStyle/>
-          <a:p>
-            <a:endParaRPr lang="es-ES" noProof="0" dirty="0"/>
-          </a:p>
-        </p:txBody>
-      </p:sp>
-      <p:sp>
-        <p:nvSpPr>
           <p:cNvPr id="10" name="TextBox 9">
             <a:extLst>
               <a:ext uri="{FF2B5EF4-FFF2-40B4-BE49-F238E27FC236}">
@@ -6335,43 +6382,6 @@
           </a:p>
         </p:txBody>
       </p:sp>
-      <p:sp>
-        <p:nvSpPr>
-          <p:cNvPr id="9" name="AutoShape 9">
-            <a:extLst>
-              <a:ext uri="{FF2B5EF4-FFF2-40B4-BE49-F238E27FC236}">
-                <a16:creationId xmlns:a16="http://schemas.microsoft.com/office/drawing/2014/main" id="{AB94063F-75F8-9982-54AF-B41D94AA0DAB}"/>
-              </a:ext>
-            </a:extLst>
-          </p:cNvPr>
-          <p:cNvSpPr/>
-          <p:nvPr/>
-        </p:nvSpPr>
-        <p:spPr>
-          <a:xfrm>
-            <a:off x="9372600" y="1485900"/>
-            <a:ext cx="7886700" cy="45975"/>
-          </a:xfrm>
-          <a:prstGeom prst="line">
-            <a:avLst/>
-          </a:prstGeom>
-          <a:ln w="38100" cap="flat">
-            <a:solidFill>
-              <a:srgbClr val="FFFFFF"/>
-            </a:solidFill>
-            <a:prstDash val="solid"/>
-            <a:headEnd type="none" w="sm" len="sm"/>
-            <a:tailEnd type="none" w="sm" len="sm"/>
-          </a:ln>
-        </p:spPr>
-        <p:txBody>
-          <a:bodyPr/>
-          <a:lstStyle/>
-          <a:p>
-            <a:endParaRPr lang="es-ES" noProof="0" dirty="0"/>
-          </a:p>
-        </p:txBody>
-      </p:sp>
       <p:pic>
         <p:nvPicPr>
           <p:cNvPr id="11" name="Imagen 10">
@@ -6394,7 +6404,7 @@
         </p:blipFill>
         <p:spPr>
           <a:xfrm>
-            <a:off x="8382000" y="3389412"/>
+            <a:off x="9372600" y="3318963"/>
             <a:ext cx="8382000" cy="6375164"/>
           </a:xfrm>
           <a:prstGeom prst="rect">
@@ -6562,6 +6572,96 @@
                 <a:sym typeface="Playfair Display"/>
               </a:rPr>
               <a:t>Líneas futuras</a:t>
+            </a:r>
+          </a:p>
+        </p:txBody>
+      </p:sp>
+      <p:pic>
+        <p:nvPicPr>
+          <p:cNvPr id="8" name="Imagen 7">
+            <a:extLst>
+              <a:ext uri="{FF2B5EF4-FFF2-40B4-BE49-F238E27FC236}">
+                <a16:creationId xmlns:a16="http://schemas.microsoft.com/office/drawing/2014/main" id="{E1064723-A722-7F4E-484C-509EAE035B4C}"/>
+              </a:ext>
+            </a:extLst>
+          </p:cNvPr>
+          <p:cNvPicPr>
+            <a:picLocks noChangeAspect="1"/>
+          </p:cNvPicPr>
+          <p:nvPr/>
+        </p:nvPicPr>
+        <p:blipFill>
+          <a:blip r:embed="rId4"/>
+          <a:srcRect r="2906"/>
+          <a:stretch>
+            <a:fillRect/>
+          </a:stretch>
+        </p:blipFill>
+        <p:spPr>
+          <a:xfrm>
+            <a:off x="727381" y="2972155"/>
+            <a:ext cx="7292669" cy="4733504"/>
+          </a:xfrm>
+          <a:prstGeom prst="rect">
+            <a:avLst/>
+          </a:prstGeom>
+        </p:spPr>
+      </p:pic>
+      <p:sp>
+        <p:nvSpPr>
+          <p:cNvPr id="13" name="TextBox 13">
+            <a:extLst>
+              <a:ext uri="{FF2B5EF4-FFF2-40B4-BE49-F238E27FC236}">
+                <a16:creationId xmlns:a16="http://schemas.microsoft.com/office/drawing/2014/main" id="{F9B9B144-9B1F-C969-01C2-7A82CE565DFD}"/>
+              </a:ext>
+            </a:extLst>
+          </p:cNvPr>
+          <p:cNvSpPr txBox="1"/>
+          <p:nvPr/>
+        </p:nvSpPr>
+        <p:spPr>
+          <a:xfrm>
+            <a:off x="4102493" y="7850320"/>
+            <a:ext cx="5270108" cy="1107996"/>
+          </a:xfrm>
+          <a:prstGeom prst="rect">
+            <a:avLst/>
+          </a:prstGeom>
+        </p:spPr>
+        <p:txBody>
+          <a:bodyPr wrap="square" lIns="0" tIns="0" rIns="0" bIns="0" rtlCol="0" anchor="t">
+            <a:spAutoFit/>
+          </a:bodyPr>
+          <a:lstStyle/>
+          <a:p>
+            <a:pPr>
+              <a:spcBef>
+                <a:spcPct val="0"/>
+              </a:spcBef>
+            </a:pPr>
+            <a:r>
+              <a:rPr lang="es-ES" sz="3600" dirty="0">
+                <a:solidFill>
+                  <a:srgbClr val="1A2161"/>
+                </a:solidFill>
+                <a:latin typeface="Open Sans"/>
+                <a:ea typeface="Open Sans"/>
+                <a:cs typeface="Open Sans"/>
+                <a:sym typeface="Open Sans"/>
+              </a:rPr>
+              <a:t>Velocidad nominal del robot </a:t>
+            </a:r>
+            <a:r>
+              <a:rPr lang="es-ES" sz="3600" noProof="0" dirty="0">
+                <a:solidFill>
+                  <a:srgbClr val="1A2161"/>
+                </a:solidFill>
+                <a:latin typeface="Open Sans"/>
+                <a:ea typeface="Open Sans"/>
+                <a:cs typeface="Open Sans"/>
+                <a:sym typeface="Open Sans"/>
+              </a:rPr>
+              <a:t>determinada</a:t>
             </a:r>
           </a:p>
         </p:txBody>
@@ -6780,136 +6880,6 @@
           </p:txBody>
         </p:sp>
       </p:grpSp>
-      <p:sp>
-        <p:nvSpPr>
-          <p:cNvPr id="6" name="TextBox 6">
-            <a:extLst>
-              <a:ext uri="{FF2B5EF4-FFF2-40B4-BE49-F238E27FC236}">
-                <a16:creationId xmlns:a16="http://schemas.microsoft.com/office/drawing/2014/main" id="{F1D1FDBF-66D7-CB4E-33B6-41184E8077A6}"/>
-              </a:ext>
-            </a:extLst>
-          </p:cNvPr>
-          <p:cNvSpPr txBox="1"/>
-          <p:nvPr/>
-        </p:nvSpPr>
-        <p:spPr>
-          <a:xfrm>
-            <a:off x="1028700" y="681193"/>
-            <a:ext cx="13982700" cy="850682"/>
-          </a:xfrm>
-          <a:prstGeom prst="rect">
-            <a:avLst/>
-          </a:prstGeom>
-        </p:spPr>
-        <p:txBody>
-          <a:bodyPr wrap="square" lIns="0" tIns="0" rIns="0" bIns="0" rtlCol="0" anchor="t">
-            <a:spAutoFit/>
-          </a:bodyPr>
-          <a:lstStyle/>
-          <a:p>
-            <a:pPr marL="0" lvl="0" indent="0">
-              <a:lnSpc>
-                <a:spcPts val="6471"/>
-              </a:lnSpc>
-              <a:spcBef>
-                <a:spcPct val="0"/>
-              </a:spcBef>
-            </a:pPr>
-            <a:r>
-              <a:rPr lang="es-ES" sz="7034" dirty="0">
-                <a:solidFill>
-                  <a:srgbClr val="FFFFFF"/>
-                </a:solidFill>
-                <a:latin typeface="Roboto Condensed" panose="02000000000000000000" pitchFamily="2" charset="0"/>
-                <a:ea typeface="Roboto Condensed" panose="02000000000000000000" pitchFamily="2" charset="0"/>
-                <a:cs typeface="Playfair Display"/>
-                <a:sym typeface="Playfair Display"/>
-              </a:rPr>
-              <a:t>8</a:t>
-            </a:r>
-            <a:r>
-              <a:rPr lang="es-ES" sz="7034" u="none" strike="noStrike" noProof="0" dirty="0">
-                <a:solidFill>
-                  <a:srgbClr val="FFFFFF"/>
-                </a:solidFill>
-                <a:latin typeface="Roboto Condensed" panose="02000000000000000000" pitchFamily="2" charset="0"/>
-                <a:ea typeface="Roboto Condensed" panose="02000000000000000000" pitchFamily="2" charset="0"/>
-                <a:cs typeface="Playfair Display"/>
-                <a:sym typeface="Playfair Display"/>
-              </a:rPr>
-              <a:t>. Línea 3: acción stop </a:t>
-            </a:r>
-          </a:p>
-        </p:txBody>
-      </p:sp>
-      <p:sp>
-        <p:nvSpPr>
-          <p:cNvPr id="9" name="AutoShape 9">
-            <a:extLst>
-              <a:ext uri="{FF2B5EF4-FFF2-40B4-BE49-F238E27FC236}">
-                <a16:creationId xmlns:a16="http://schemas.microsoft.com/office/drawing/2014/main" id="{FCC3CD0E-61A1-3CA4-62B5-59D4DD470542}"/>
-              </a:ext>
-            </a:extLst>
-          </p:cNvPr>
-          <p:cNvSpPr/>
-          <p:nvPr/>
-        </p:nvSpPr>
-        <p:spPr>
-          <a:xfrm>
-            <a:off x="9339210" y="1022482"/>
-            <a:ext cx="7886700" cy="45975"/>
-          </a:xfrm>
-          <a:prstGeom prst="line">
-            <a:avLst/>
-          </a:prstGeom>
-          <a:ln w="38100" cap="flat">
-            <a:solidFill>
-              <a:srgbClr val="FFFFFF"/>
-            </a:solidFill>
-            <a:prstDash val="solid"/>
-            <a:headEnd type="none" w="sm" len="sm"/>
-            <a:tailEnd type="none" w="sm" len="sm"/>
-          </a:ln>
-        </p:spPr>
-        <p:txBody>
-          <a:bodyPr/>
-          <a:lstStyle/>
-          <a:p>
-            <a:endParaRPr lang="es-ES" noProof="0" dirty="0"/>
-          </a:p>
-        </p:txBody>
-      </p:sp>
-      <p:pic>
-        <p:nvPicPr>
-          <p:cNvPr id="8" name="Imagen 7">
-            <a:extLst>
-              <a:ext uri="{FF2B5EF4-FFF2-40B4-BE49-F238E27FC236}">
-                <a16:creationId xmlns:a16="http://schemas.microsoft.com/office/drawing/2014/main" id="{A9EC36AE-A36E-B38C-ECB4-A0F5ED43AE3A}"/>
-              </a:ext>
-            </a:extLst>
-          </p:cNvPr>
-          <p:cNvPicPr>
-            <a:picLocks noChangeAspect="1"/>
-          </p:cNvPicPr>
-          <p:nvPr/>
-        </p:nvPicPr>
-        <p:blipFill>
-          <a:blip r:embed="rId3"/>
-          <a:srcRect r="2906"/>
-          <a:stretch>
-            <a:fillRect/>
-          </a:stretch>
-        </p:blipFill>
-        <p:spPr>
-          <a:xfrm>
-            <a:off x="536882" y="2456390"/>
-            <a:ext cx="8279787" cy="5374220"/>
-          </a:xfrm>
-          <a:prstGeom prst="rect">
-            <a:avLst/>
-          </a:prstGeom>
-        </p:spPr>
-      </p:pic>
       <p:pic>
         <p:nvPicPr>
           <p:cNvPr id="10" name="Imagen 9">
@@ -6925,7 +6895,7 @@
           <p:nvPr/>
         </p:nvPicPr>
         <p:blipFill>
-          <a:blip r:embed="rId4"/>
+          <a:blip r:embed="rId3"/>
           <a:srcRect r="2936"/>
           <a:stretch>
             <a:fillRect/>
@@ -6955,7 +6925,7 @@
         </p:nvSpPr>
         <p:spPr>
           <a:xfrm>
-            <a:off x="9719193" y="6031111"/>
+            <a:off x="9895239" y="7048500"/>
             <a:ext cx="7730607" cy="2215991"/>
           </a:xfrm>
           <a:prstGeom prst="rect">
@@ -7192,6 +7162,128 @@
                 <a:sym typeface="Playfair Display"/>
               </a:rPr>
               <a:t>Líneas futuras</a:t>
+            </a:r>
+          </a:p>
+        </p:txBody>
+      </p:sp>
+      <p:pic>
+        <p:nvPicPr>
+          <p:cNvPr id="17" name="Picture 16">
+            <a:extLst>
+              <a:ext uri="{FF2B5EF4-FFF2-40B4-BE49-F238E27FC236}">
+                <a16:creationId xmlns:a16="http://schemas.microsoft.com/office/drawing/2014/main" id="{7BA1590E-5883-FD7C-0809-2240090F8880}"/>
+              </a:ext>
+            </a:extLst>
+          </p:cNvPr>
+          <p:cNvPicPr>
+            <a:picLocks noChangeAspect="1"/>
+          </p:cNvPicPr>
+          <p:nvPr/>
+        </p:nvPicPr>
+        <p:blipFill>
+          <a:blip r:embed="rId4"/>
+          <a:stretch>
+            <a:fillRect/>
+          </a:stretch>
+        </p:blipFill>
+        <p:spPr>
+          <a:xfrm>
+            <a:off x="172010" y="2799979"/>
+            <a:ext cx="8992939" cy="3791321"/>
+          </a:xfrm>
+          <a:prstGeom prst="rect">
+            <a:avLst/>
+          </a:prstGeom>
+        </p:spPr>
+      </p:pic>
+      <p:pic>
+        <p:nvPicPr>
+          <p:cNvPr id="19" name="Picture 18">
+            <a:extLst>
+              <a:ext uri="{FF2B5EF4-FFF2-40B4-BE49-F238E27FC236}">
+                <a16:creationId xmlns:a16="http://schemas.microsoft.com/office/drawing/2014/main" id="{6F22D15D-03B6-F1E6-A9EB-CEDEA7EE7900}"/>
+              </a:ext>
+            </a:extLst>
+          </p:cNvPr>
+          <p:cNvPicPr>
+            <a:picLocks noChangeAspect="1"/>
+          </p:cNvPicPr>
+          <p:nvPr/>
+        </p:nvPicPr>
+        <p:blipFill>
+          <a:blip r:embed="rId5"/>
+          <a:stretch>
+            <a:fillRect/>
+          </a:stretch>
+        </p:blipFill>
+        <p:spPr>
+          <a:xfrm>
+            <a:off x="1600200" y="6657596"/>
+            <a:ext cx="6203118" cy="532171"/>
+          </a:xfrm>
+          <a:prstGeom prst="rect">
+            <a:avLst/>
+          </a:prstGeom>
+        </p:spPr>
+      </p:pic>
+      <p:sp>
+        <p:nvSpPr>
+          <p:cNvPr id="8" name="TextBox 6">
+            <a:extLst>
+              <a:ext uri="{FF2B5EF4-FFF2-40B4-BE49-F238E27FC236}">
+                <a16:creationId xmlns:a16="http://schemas.microsoft.com/office/drawing/2014/main" id="{E1CB968B-6999-BFAF-B525-2ED7361A497B}"/>
+              </a:ext>
+            </a:extLst>
+          </p:cNvPr>
+          <p:cNvSpPr txBox="1"/>
+          <p:nvPr/>
+        </p:nvSpPr>
+        <p:spPr>
+          <a:xfrm>
+            <a:off x="1028700" y="1200110"/>
+            <a:ext cx="13982700" cy="850682"/>
+          </a:xfrm>
+          <a:prstGeom prst="rect">
+            <a:avLst/>
+          </a:prstGeom>
+        </p:spPr>
+        <p:txBody>
+          <a:bodyPr wrap="square" lIns="0" tIns="0" rIns="0" bIns="0" rtlCol="0" anchor="t">
+            <a:spAutoFit/>
+          </a:bodyPr>
+          <a:lstStyle/>
+          <a:p>
+            <a:pPr marL="0" lvl="0" indent="0">
+              <a:lnSpc>
+                <a:spcPts val="6471"/>
+              </a:lnSpc>
+              <a:spcBef>
+                <a:spcPct val="0"/>
+              </a:spcBef>
+            </a:pPr>
+            <a:r>
+              <a:rPr lang="es-ES" sz="7034" dirty="0">
+                <a:solidFill>
+                  <a:srgbClr val="FFFFFF"/>
+                </a:solidFill>
+                <a:latin typeface="Roboto Condensed" panose="02000000000000000000" pitchFamily="2" charset="0"/>
+                <a:ea typeface="Roboto Condensed" panose="02000000000000000000" pitchFamily="2" charset="0"/>
+                <a:cs typeface="Playfair Display"/>
+                <a:sym typeface="Playfair Display"/>
+              </a:rPr>
+              <a:t>8</a:t>
+            </a:r>
+            <a:r>
+              <a:rPr lang="es-ES" sz="7034" u="none" strike="noStrike" noProof="0" dirty="0">
+                <a:solidFill>
+                  <a:srgbClr val="FFFFFF"/>
+                </a:solidFill>
+                <a:latin typeface="Roboto Condensed" panose="02000000000000000000" pitchFamily="2" charset="0"/>
+                <a:ea typeface="Roboto Condensed" panose="02000000000000000000" pitchFamily="2" charset="0"/>
+                <a:cs typeface="Playfair Display"/>
+                <a:sym typeface="Playfair Display"/>
+              </a:rPr>
+              <a:t>. Línea 3: acción stop </a:t>
             </a:r>
           </a:p>
         </p:txBody>
@@ -7491,49 +7583,12 @@
           </a:p>
         </p:txBody>
       </p:sp>
-      <p:sp>
-        <p:nvSpPr>
-          <p:cNvPr id="9" name="AutoShape 9">
+      <p:pic>
+        <p:nvPicPr>
+          <p:cNvPr id="11" name="Imagen 10">
             <a:extLst>
               <a:ext uri="{FF2B5EF4-FFF2-40B4-BE49-F238E27FC236}">
-                <a16:creationId xmlns:a16="http://schemas.microsoft.com/office/drawing/2014/main" id="{76EA6BD8-5F0D-DD79-6683-7E76AEFEC41E}"/>
-              </a:ext>
-            </a:extLst>
-          </p:cNvPr>
-          <p:cNvSpPr/>
-          <p:nvPr/>
-        </p:nvSpPr>
-        <p:spPr>
-          <a:xfrm>
-            <a:off x="13258800" y="1485900"/>
-            <a:ext cx="4000500" cy="45975"/>
-          </a:xfrm>
-          <a:prstGeom prst="line">
-            <a:avLst/>
-          </a:prstGeom>
-          <a:ln w="38100" cap="flat">
-            <a:solidFill>
-              <a:srgbClr val="FFFFFF"/>
-            </a:solidFill>
-            <a:prstDash val="solid"/>
-            <a:headEnd type="none" w="sm" len="sm"/>
-            <a:tailEnd type="none" w="sm" len="sm"/>
-          </a:ln>
-        </p:spPr>
-        <p:txBody>
-          <a:bodyPr/>
-          <a:lstStyle/>
-          <a:p>
-            <a:endParaRPr lang="es-ES" noProof="0" dirty="0"/>
-          </a:p>
-        </p:txBody>
-      </p:sp>
-      <p:pic>
-        <p:nvPicPr>
-          <p:cNvPr id="8" name="Imagen 7">
-            <a:extLst>
-              <a:ext uri="{FF2B5EF4-FFF2-40B4-BE49-F238E27FC236}">
-                <a16:creationId xmlns:a16="http://schemas.microsoft.com/office/drawing/2014/main" id="{1B9487F3-EB1E-C1E1-03DF-1215D160A93F}"/>
+                <a16:creationId xmlns:a16="http://schemas.microsoft.com/office/drawing/2014/main" id="{F9ABFCBC-F347-FFD8-BB3F-D06DD3919F88}"/>
               </a:ext>
             </a:extLst>
           </p:cNvPr>
@@ -7550,74 +7605,290 @@
         </p:blipFill>
         <p:spPr>
           <a:xfrm>
-            <a:off x="10972800" y="43289"/>
-            <a:ext cx="6477000" cy="5257958"/>
+            <a:off x="5845967" y="3421824"/>
+            <a:ext cx="12300864" cy="6337909"/>
           </a:xfrm>
           <a:prstGeom prst="rect">
             <a:avLst/>
           </a:prstGeom>
         </p:spPr>
       </p:pic>
-      <p:pic>
-        <p:nvPicPr>
-          <p:cNvPr id="11" name="Imagen 10">
+      <p:sp>
+        <p:nvSpPr>
+          <p:cNvPr id="8" name="TextBox 9">
             <a:extLst>
               <a:ext uri="{FF2B5EF4-FFF2-40B4-BE49-F238E27FC236}">
-                <a16:creationId xmlns:a16="http://schemas.microsoft.com/office/drawing/2014/main" id="{F9ABFCBC-F347-FFD8-BB3F-D06DD3919F88}"/>
+                <a16:creationId xmlns:a16="http://schemas.microsoft.com/office/drawing/2014/main" id="{60D724EF-18EF-B0F4-2251-2BB618A38C5F}"/>
               </a:ext>
             </a:extLst>
           </p:cNvPr>
-          <p:cNvPicPr>
-            <a:picLocks noChangeAspect="1"/>
-          </p:cNvPicPr>
+          <p:cNvSpPr txBox="1"/>
           <p:nvPr/>
-        </p:nvPicPr>
-        <p:blipFill>
-          <a:blip r:embed="rId4"/>
-          <a:stretch>
-            <a:fillRect/>
-          </a:stretch>
-        </p:blipFill>
+        </p:nvSpPr>
         <p:spPr>
           <a:xfrm>
-            <a:off x="353705" y="3027951"/>
-            <a:ext cx="10700108" cy="5513134"/>
+            <a:off x="172010" y="7753997"/>
+            <a:ext cx="3574219" cy="2174954"/>
           </a:xfrm>
           <a:prstGeom prst="rect">
             <a:avLst/>
           </a:prstGeom>
         </p:spPr>
-      </p:pic>
-      <p:pic>
-        <p:nvPicPr>
-          <p:cNvPr id="13" name="Imagen 12">
+        <p:txBody>
+          <a:bodyPr wrap="square" lIns="0" tIns="0" rIns="0" bIns="0" rtlCol="0" anchor="t">
+            <a:spAutoFit/>
+          </a:bodyPr>
+          <a:lstStyle/>
+          <a:p>
+            <a:pPr marL="939494" lvl="1" indent="-469747" algn="l">
+              <a:lnSpc>
+                <a:spcPct val="150000"/>
+              </a:lnSpc>
+              <a:buFont typeface="+mj-lt"/>
+              <a:buAutoNum type="arabicPeriod" startAt="7"/>
+            </a:pPr>
+            <a:r>
+              <a:rPr lang="es-ES" sz="1600" noProof="0" dirty="0">
+                <a:solidFill>
+                  <a:schemeClr val="tx2">
+                    <a:lumMod val="40000"/>
+                    <a:lumOff val="60000"/>
+                  </a:schemeClr>
+                </a:solidFill>
+                <a:latin typeface="Roboto Condensed" panose="02000000000000000000" pitchFamily="2" charset="0"/>
+                <a:ea typeface="Roboto Condensed" panose="02000000000000000000" pitchFamily="2" charset="0"/>
+                <a:cs typeface="Playfair Display"/>
+                <a:sym typeface="Playfair Display"/>
+              </a:rPr>
+              <a:t>Línea 2: recompensa dispersa</a:t>
+            </a:r>
+          </a:p>
+          <a:p>
+            <a:pPr marL="939494" lvl="1" indent="-469747" algn="l">
+              <a:lnSpc>
+                <a:spcPct val="150000"/>
+              </a:lnSpc>
+              <a:buAutoNum type="arabicPeriod" startAt="7"/>
+            </a:pPr>
+            <a:r>
+              <a:rPr lang="es-ES" sz="1600" noProof="0" dirty="0">
+                <a:solidFill>
+                  <a:schemeClr val="accent1">
+                    <a:lumMod val="60000"/>
+                    <a:lumOff val="40000"/>
+                  </a:schemeClr>
+                </a:solidFill>
+                <a:latin typeface="Roboto Condensed" panose="02000000000000000000" pitchFamily="2" charset="0"/>
+                <a:ea typeface="Roboto Condensed" panose="02000000000000000000" pitchFamily="2" charset="0"/>
+                <a:cs typeface="Playfair Display"/>
+                <a:sym typeface="Playfair Display"/>
+              </a:rPr>
+              <a:t>Línea 3: acción stop </a:t>
+            </a:r>
+          </a:p>
+          <a:p>
+            <a:pPr marL="939494" lvl="1" indent="-469747" algn="l">
+              <a:lnSpc>
+                <a:spcPct val="150000"/>
+              </a:lnSpc>
+              <a:buAutoNum type="arabicPeriod" startAt="7"/>
+            </a:pPr>
+            <a:r>
+              <a:rPr lang="es-ES" sz="1600" noProof="0" dirty="0">
+                <a:solidFill>
+                  <a:schemeClr val="tx2"/>
+                </a:solidFill>
+                <a:latin typeface="Roboto Condensed" panose="02000000000000000000" pitchFamily="2" charset="0"/>
+                <a:ea typeface="Roboto Condensed" panose="02000000000000000000" pitchFamily="2" charset="0"/>
+                <a:cs typeface="Playfair Display"/>
+                <a:sym typeface="Playfair Display"/>
+              </a:rPr>
+              <a:t>Línea 4: información temporal</a:t>
+            </a:r>
+          </a:p>
+          <a:p>
+            <a:pPr marL="939494" lvl="1" indent="-469747" algn="l">
+              <a:lnSpc>
+                <a:spcPct val="150000"/>
+              </a:lnSpc>
+              <a:buAutoNum type="arabicPeriod" startAt="7"/>
+            </a:pPr>
+            <a:r>
+              <a:rPr lang="es-ES" sz="1600" noProof="0" dirty="0">
+                <a:solidFill>
+                  <a:schemeClr val="tx2">
+                    <a:lumMod val="40000"/>
+                    <a:lumOff val="60000"/>
+                  </a:schemeClr>
+                </a:solidFill>
+                <a:latin typeface="Roboto Condensed" panose="02000000000000000000" pitchFamily="2" charset="0"/>
+                <a:ea typeface="Roboto Condensed" panose="02000000000000000000" pitchFamily="2" charset="0"/>
+                <a:cs typeface="Playfair Display"/>
+                <a:sym typeface="Playfair Display"/>
+              </a:rPr>
+              <a:t>Demostración</a:t>
+            </a:r>
+          </a:p>
+          <a:p>
+            <a:pPr marL="939494" lvl="1" indent="-469747" algn="l">
+              <a:lnSpc>
+                <a:spcPct val="150000"/>
+              </a:lnSpc>
+              <a:buAutoNum type="arabicPeriod" startAt="7"/>
+            </a:pPr>
+            <a:r>
+              <a:rPr lang="es-ES" sz="1600" noProof="0" dirty="0">
+                <a:solidFill>
+                  <a:schemeClr val="tx2">
+                    <a:lumMod val="40000"/>
+                    <a:lumOff val="60000"/>
+                  </a:schemeClr>
+                </a:solidFill>
+                <a:latin typeface="Roboto Condensed" panose="02000000000000000000" pitchFamily="2" charset="0"/>
+                <a:ea typeface="Roboto Condensed" panose="02000000000000000000" pitchFamily="2" charset="0"/>
+                <a:cs typeface="Playfair Display"/>
+                <a:sym typeface="Playfair Display"/>
+              </a:rPr>
+              <a:t>Conclusiones</a:t>
+            </a:r>
+          </a:p>
+          <a:p>
+            <a:pPr marL="939494" lvl="1" indent="-469747" algn="l">
+              <a:lnSpc>
+                <a:spcPct val="150000"/>
+              </a:lnSpc>
+              <a:buAutoNum type="arabicPeriod" startAt="7"/>
+            </a:pPr>
+            <a:r>
+              <a:rPr lang="es-ES" sz="1600" noProof="0" dirty="0">
+                <a:solidFill>
+                  <a:schemeClr val="tx2">
+                    <a:lumMod val="40000"/>
+                    <a:lumOff val="60000"/>
+                  </a:schemeClr>
+                </a:solidFill>
+                <a:latin typeface="Roboto Condensed" panose="02000000000000000000" pitchFamily="2" charset="0"/>
+                <a:ea typeface="Roboto Condensed" panose="02000000000000000000" pitchFamily="2" charset="0"/>
+                <a:cs typeface="Playfair Display"/>
+                <a:sym typeface="Playfair Display"/>
+              </a:rPr>
+              <a:t>Líneas futuras</a:t>
+            </a:r>
+          </a:p>
+        </p:txBody>
+      </p:sp>
+      <p:sp>
+        <p:nvSpPr>
+          <p:cNvPr id="12" name="TextBox 13">
             <a:extLst>
               <a:ext uri="{FF2B5EF4-FFF2-40B4-BE49-F238E27FC236}">
-                <a16:creationId xmlns:a16="http://schemas.microsoft.com/office/drawing/2014/main" id="{F155285A-4740-BED4-27B7-CE958F3F4EC5}"/>
+                <a16:creationId xmlns:a16="http://schemas.microsoft.com/office/drawing/2014/main" id="{47ED5CD1-2A45-DE7C-DEF0-748B64397786}"/>
               </a:ext>
             </a:extLst>
           </p:cNvPr>
-          <p:cNvPicPr>
-            <a:picLocks noChangeAspect="1"/>
-          </p:cNvPicPr>
+          <p:cNvSpPr txBox="1"/>
           <p:nvPr/>
-        </p:nvPicPr>
-        <p:blipFill>
-          <a:blip r:embed="rId5"/>
-          <a:stretch>
-            <a:fillRect/>
-          </a:stretch>
-        </p:blipFill>
+        </p:nvSpPr>
         <p:spPr>
           <a:xfrm>
-            <a:off x="11094225" y="5290041"/>
-            <a:ext cx="6012374" cy="4732077"/>
+            <a:off x="533401" y="3695700"/>
+            <a:ext cx="5562600" cy="1661993"/>
           </a:xfrm>
           <a:prstGeom prst="rect">
             <a:avLst/>
           </a:prstGeom>
         </p:spPr>
-      </p:pic>
+        <p:txBody>
+          <a:bodyPr wrap="square" lIns="0" tIns="0" rIns="0" bIns="0" rtlCol="0" anchor="t">
+            <a:spAutoFit/>
+          </a:bodyPr>
+          <a:lstStyle/>
+          <a:p>
+            <a:pPr>
+              <a:spcBef>
+                <a:spcPct val="0"/>
+              </a:spcBef>
+            </a:pPr>
+            <a:r>
+              <a:rPr lang="es-ES" sz="3600" dirty="0">
+                <a:solidFill>
+                  <a:srgbClr val="1A2161"/>
+                </a:solidFill>
+                <a:latin typeface="Open Sans"/>
+                <a:ea typeface="Open Sans"/>
+                <a:cs typeface="Open Sans"/>
+                <a:sym typeface="Open Sans"/>
+              </a:rPr>
+              <a:t>Información temporal </a:t>
+            </a:r>
+          </a:p>
+          <a:p>
+            <a:pPr>
+              <a:spcBef>
+                <a:spcPct val="0"/>
+              </a:spcBef>
+            </a:pPr>
+            <a:r>
+              <a:rPr lang="es-ES" sz="3600" noProof="0" dirty="0">
+                <a:solidFill>
+                  <a:srgbClr val="1A2161"/>
+                </a:solidFill>
+                <a:latin typeface="Open Sans"/>
+                <a:ea typeface="Open Sans"/>
+                <a:cs typeface="Open Sans"/>
+                <a:sym typeface="Open Sans"/>
+              </a:rPr>
+              <a:t>Mayor contexto para la toma de decisiones</a:t>
+            </a:r>
+          </a:p>
+        </p:txBody>
+      </p:sp>
+      <p:cxnSp>
+        <p:nvCxnSpPr>
+          <p:cNvPr id="13" name="Conector recto de flecha 11">
+            <a:extLst>
+              <a:ext uri="{FF2B5EF4-FFF2-40B4-BE49-F238E27FC236}">
+                <a16:creationId xmlns:a16="http://schemas.microsoft.com/office/drawing/2014/main" id="{1DC6D616-0CA6-57F5-6E55-C5DE945DCF93}"/>
+              </a:ext>
+            </a:extLst>
+          </p:cNvPr>
+          <p:cNvCxnSpPr>
+            <a:cxnSpLocks/>
+          </p:cNvCxnSpPr>
+          <p:nvPr/>
+        </p:nvCxnSpPr>
+        <p:spPr>
+          <a:xfrm>
+            <a:off x="5334000" y="4000500"/>
+            <a:ext cx="381000" cy="0"/>
+          </a:xfrm>
+          <a:prstGeom prst="straightConnector1">
+            <a:avLst/>
+          </a:prstGeom>
+          <a:ln w="57150">
+            <a:solidFill>
+              <a:schemeClr val="tx2">
+                <a:lumMod val="50000"/>
+              </a:schemeClr>
+            </a:solidFill>
+            <a:tailEnd type="triangle"/>
+          </a:ln>
+        </p:spPr>
+        <p:style>
+          <a:lnRef idx="1">
+            <a:schemeClr val="accent1"/>
+          </a:lnRef>
+          <a:fillRef idx="0">
+            <a:schemeClr val="accent1"/>
+          </a:fillRef>
+          <a:effectRef idx="0">
+            <a:schemeClr val="accent1"/>
+          </a:effectRef>
+          <a:fontRef idx="minor">
+            <a:schemeClr val="tx1"/>
+          </a:fontRef>
+        </p:style>
+      </p:cxnSp>
     </p:spTree>
     <p:extLst>
       <p:ext uri="{BB962C8B-B14F-4D97-AF65-F5344CB8AC3E}">
@@ -7676,7 +7947,7 @@
         </p:nvSpPr>
         <p:spPr>
           <a:xfrm rot="-10800000">
-            <a:off x="104775" y="1745916"/>
+            <a:off x="104775" y="878535"/>
             <a:ext cx="18078450" cy="1643495"/>
           </a:xfrm>
           <a:custGeom>
@@ -7735,8 +8006,8 @@
         </p:nvGrpSpPr>
         <p:grpSpPr>
           <a:xfrm>
-            <a:off x="0" y="2994333"/>
-            <a:ext cx="18288000" cy="7024424"/>
+            <a:off x="0" y="2324100"/>
+            <a:ext cx="18288000" cy="7694657"/>
             <a:chOff x="0" y="0"/>
             <a:chExt cx="5186228" cy="1850054"/>
           </a:xfrm>
@@ -7846,8 +8117,8 @@
         </p:nvSpPr>
         <p:spPr>
           <a:xfrm>
-            <a:off x="989760" y="527266"/>
-            <a:ext cx="7810500" cy="2500685"/>
+            <a:off x="990600" y="780256"/>
+            <a:ext cx="13335840" cy="1667123"/>
           </a:xfrm>
           <a:prstGeom prst="rect">
             <a:avLst/>
@@ -7910,43 +8181,6 @@
               <a:cs typeface="Playfair Display"/>
               <a:sym typeface="Playfair Display"/>
             </a:endParaRPr>
-          </a:p>
-        </p:txBody>
-      </p:sp>
-      <p:sp>
-        <p:nvSpPr>
-          <p:cNvPr id="9" name="AutoShape 9">
-            <a:extLst>
-              <a:ext uri="{FF2B5EF4-FFF2-40B4-BE49-F238E27FC236}">
-                <a16:creationId xmlns:a16="http://schemas.microsoft.com/office/drawing/2014/main" id="{068CEC4E-820E-E95D-8077-2CFE2104BE96}"/>
-              </a:ext>
-            </a:extLst>
-          </p:cNvPr>
-          <p:cNvSpPr/>
-          <p:nvPr/>
-        </p:nvSpPr>
-        <p:spPr>
-          <a:xfrm>
-            <a:off x="13258800" y="1485900"/>
-            <a:ext cx="4000500" cy="45975"/>
-          </a:xfrm>
-          <a:prstGeom prst="line">
-            <a:avLst/>
-          </a:prstGeom>
-          <a:ln w="38100" cap="flat">
-            <a:solidFill>
-              <a:srgbClr val="FFFFFF"/>
-            </a:solidFill>
-            <a:prstDash val="solid"/>
-            <a:headEnd type="none" w="sm" len="sm"/>
-            <a:tailEnd type="none" w="sm" len="sm"/>
-          </a:ln>
-        </p:spPr>
-        <p:txBody>
-          <a:bodyPr/>
-          <a:lstStyle/>
-          <a:p>
-            <a:endParaRPr lang="es-ES" noProof="0" dirty="0"/>
           </a:p>
         </p:txBody>
       </p:sp>
@@ -7972,38 +8206,8 @@
         </p:blipFill>
         <p:spPr>
           <a:xfrm>
-            <a:off x="10972800" y="43289"/>
-            <a:ext cx="6477000" cy="5257958"/>
-          </a:xfrm>
-          <a:prstGeom prst="rect">
-            <a:avLst/>
-          </a:prstGeom>
-        </p:spPr>
-      </p:pic>
-      <p:pic>
-        <p:nvPicPr>
-          <p:cNvPr id="11" name="Imagen 10">
-            <a:extLst>
-              <a:ext uri="{FF2B5EF4-FFF2-40B4-BE49-F238E27FC236}">
-                <a16:creationId xmlns:a16="http://schemas.microsoft.com/office/drawing/2014/main" id="{80EF8C21-53CF-F73D-09B1-680F1DC5DB8E}"/>
-              </a:ext>
-            </a:extLst>
-          </p:cNvPr>
-          <p:cNvPicPr>
-            <a:picLocks noChangeAspect="1"/>
-          </p:cNvPicPr>
-          <p:nvPr/>
-        </p:nvPicPr>
-        <p:blipFill>
-          <a:blip r:embed="rId4"/>
-          <a:stretch>
-            <a:fillRect/>
-          </a:stretch>
-        </p:blipFill>
-        <p:spPr>
-          <a:xfrm>
-            <a:off x="353705" y="3027951"/>
-            <a:ext cx="10700108" cy="5513134"/>
+            <a:off x="3276600" y="2447380"/>
+            <a:ext cx="7032922" cy="5709250"/>
           </a:xfrm>
           <a:prstGeom prst="rect">
             <a:avLst/>
@@ -8025,21 +8229,232 @@
           <p:nvPr/>
         </p:nvPicPr>
         <p:blipFill>
-          <a:blip r:embed="rId5"/>
+          <a:blip r:embed="rId4"/>
           <a:stretch>
             <a:fillRect/>
           </a:stretch>
         </p:blipFill>
         <p:spPr>
           <a:xfrm>
-            <a:off x="11094225" y="5290041"/>
-            <a:ext cx="6012374" cy="4732077"/>
+            <a:off x="10309522" y="2504000"/>
+            <a:ext cx="7871428" cy="6195257"/>
           </a:xfrm>
           <a:prstGeom prst="rect">
             <a:avLst/>
           </a:prstGeom>
         </p:spPr>
       </p:pic>
+      <p:sp>
+        <p:nvSpPr>
+          <p:cNvPr id="9" name="TextBox 13">
+            <a:extLst>
+              <a:ext uri="{FF2B5EF4-FFF2-40B4-BE49-F238E27FC236}">
+                <a16:creationId xmlns:a16="http://schemas.microsoft.com/office/drawing/2014/main" id="{3C699FE2-4E26-D931-8514-43AC3E414A8F}"/>
+              </a:ext>
+            </a:extLst>
+          </p:cNvPr>
+          <p:cNvSpPr txBox="1"/>
+          <p:nvPr/>
+        </p:nvSpPr>
+        <p:spPr>
+          <a:xfrm>
+            <a:off x="2667000" y="8830530"/>
+            <a:ext cx="16036407" cy="1107996"/>
+          </a:xfrm>
+          <a:prstGeom prst="rect">
+            <a:avLst/>
+          </a:prstGeom>
+        </p:spPr>
+        <p:txBody>
+          <a:bodyPr wrap="square" lIns="0" tIns="0" rIns="0" bIns="0" rtlCol="0" anchor="t">
+            <a:spAutoFit/>
+          </a:bodyPr>
+          <a:lstStyle/>
+          <a:p>
+            <a:pPr>
+              <a:spcBef>
+                <a:spcPct val="0"/>
+              </a:spcBef>
+            </a:pPr>
+            <a:r>
+              <a:rPr lang="es-ES" sz="3600" noProof="0" dirty="0">
+                <a:solidFill>
+                  <a:srgbClr val="1A2161"/>
+                </a:solidFill>
+                <a:latin typeface="Open Sans"/>
+                <a:ea typeface="Open Sans"/>
+                <a:cs typeface="Open Sans"/>
+                <a:sym typeface="Open Sans"/>
+              </a:rPr>
+              <a:t>La presión temporal no mejora el balance, pero induce recargas más conservadoras</a:t>
+            </a:r>
+          </a:p>
+        </p:txBody>
+      </p:sp>
+      <p:sp>
+        <p:nvSpPr>
+          <p:cNvPr id="11" name="TextBox 9">
+            <a:extLst>
+              <a:ext uri="{FF2B5EF4-FFF2-40B4-BE49-F238E27FC236}">
+                <a16:creationId xmlns:a16="http://schemas.microsoft.com/office/drawing/2014/main" id="{D8BC8EF5-925B-71C6-27FF-6F553991521D}"/>
+              </a:ext>
+            </a:extLst>
+          </p:cNvPr>
+          <p:cNvSpPr txBox="1"/>
+          <p:nvPr/>
+        </p:nvSpPr>
+        <p:spPr>
+          <a:xfrm>
+            <a:off x="172010" y="7753997"/>
+            <a:ext cx="3574219" cy="2174954"/>
+          </a:xfrm>
+          <a:prstGeom prst="rect">
+            <a:avLst/>
+          </a:prstGeom>
+        </p:spPr>
+        <p:txBody>
+          <a:bodyPr wrap="square" lIns="0" tIns="0" rIns="0" bIns="0" rtlCol="0" anchor="t">
+            <a:spAutoFit/>
+          </a:bodyPr>
+          <a:lstStyle/>
+          <a:p>
+            <a:pPr marL="939494" lvl="1" indent="-469747" algn="l">
+              <a:lnSpc>
+                <a:spcPct val="150000"/>
+              </a:lnSpc>
+              <a:buFont typeface="+mj-lt"/>
+              <a:buAutoNum type="arabicPeriod" startAt="7"/>
+            </a:pPr>
+            <a:r>
+              <a:rPr lang="es-ES" sz="1600" noProof="0" dirty="0">
+                <a:solidFill>
+                  <a:schemeClr val="tx2">
+                    <a:lumMod val="40000"/>
+                    <a:lumOff val="60000"/>
+                  </a:schemeClr>
+                </a:solidFill>
+                <a:latin typeface="Roboto Condensed" panose="02000000000000000000" pitchFamily="2" charset="0"/>
+                <a:ea typeface="Roboto Condensed" panose="02000000000000000000" pitchFamily="2" charset="0"/>
+                <a:cs typeface="Playfair Display"/>
+                <a:sym typeface="Playfair Display"/>
+              </a:rPr>
+              <a:t>Línea 2: recompensa dispersa</a:t>
+            </a:r>
+          </a:p>
+          <a:p>
+            <a:pPr marL="939494" lvl="1" indent="-469747" algn="l">
+              <a:lnSpc>
+                <a:spcPct val="150000"/>
+              </a:lnSpc>
+              <a:buAutoNum type="arabicPeriod" startAt="7"/>
+            </a:pPr>
+            <a:r>
+              <a:rPr lang="es-ES" sz="1600" noProof="0" dirty="0">
+                <a:solidFill>
+                  <a:schemeClr val="accent1">
+                    <a:lumMod val="60000"/>
+                    <a:lumOff val="40000"/>
+                  </a:schemeClr>
+                </a:solidFill>
+                <a:latin typeface="Roboto Condensed" panose="02000000000000000000" pitchFamily="2" charset="0"/>
+                <a:ea typeface="Roboto Condensed" panose="02000000000000000000" pitchFamily="2" charset="0"/>
+                <a:cs typeface="Playfair Display"/>
+                <a:sym typeface="Playfair Display"/>
+              </a:rPr>
+              <a:t>Línea 3: acción stop </a:t>
+            </a:r>
+          </a:p>
+          <a:p>
+            <a:pPr marL="939494" lvl="1" indent="-469747" algn="l">
+              <a:lnSpc>
+                <a:spcPct val="150000"/>
+              </a:lnSpc>
+              <a:buAutoNum type="arabicPeriod" startAt="7"/>
+            </a:pPr>
+            <a:r>
+              <a:rPr lang="es-ES" sz="1600" noProof="0" dirty="0">
+                <a:solidFill>
+                  <a:schemeClr val="tx2"/>
+                </a:solidFill>
+                <a:latin typeface="Roboto Condensed" panose="02000000000000000000" pitchFamily="2" charset="0"/>
+                <a:ea typeface="Roboto Condensed" panose="02000000000000000000" pitchFamily="2" charset="0"/>
+                <a:cs typeface="Playfair Display"/>
+                <a:sym typeface="Playfair Display"/>
+              </a:rPr>
+              <a:t>Línea 4: información temporal</a:t>
+            </a:r>
+          </a:p>
+          <a:p>
+            <a:pPr marL="939494" lvl="1" indent="-469747" algn="l">
+              <a:lnSpc>
+                <a:spcPct val="150000"/>
+              </a:lnSpc>
+              <a:buAutoNum type="arabicPeriod" startAt="7"/>
+            </a:pPr>
+            <a:r>
+              <a:rPr lang="es-ES" sz="1600" noProof="0" dirty="0">
+                <a:solidFill>
+                  <a:schemeClr val="tx2">
+                    <a:lumMod val="40000"/>
+                    <a:lumOff val="60000"/>
+                  </a:schemeClr>
+                </a:solidFill>
+                <a:latin typeface="Roboto Condensed" panose="02000000000000000000" pitchFamily="2" charset="0"/>
+                <a:ea typeface="Roboto Condensed" panose="02000000000000000000" pitchFamily="2" charset="0"/>
+                <a:cs typeface="Playfair Display"/>
+                <a:sym typeface="Playfair Display"/>
+              </a:rPr>
+              <a:t>Demostración</a:t>
+            </a:r>
+          </a:p>
+          <a:p>
+            <a:pPr marL="939494" lvl="1" indent="-469747" algn="l">
+              <a:lnSpc>
+                <a:spcPct val="150000"/>
+              </a:lnSpc>
+              <a:buAutoNum type="arabicPeriod" startAt="7"/>
+            </a:pPr>
+            <a:r>
+              <a:rPr lang="es-ES" sz="1600" noProof="0" dirty="0">
+                <a:solidFill>
+                  <a:schemeClr val="tx2">
+                    <a:lumMod val="40000"/>
+                    <a:lumOff val="60000"/>
+                  </a:schemeClr>
+                </a:solidFill>
+                <a:latin typeface="Roboto Condensed" panose="02000000000000000000" pitchFamily="2" charset="0"/>
+                <a:ea typeface="Roboto Condensed" panose="02000000000000000000" pitchFamily="2" charset="0"/>
+                <a:cs typeface="Playfair Display"/>
+                <a:sym typeface="Playfair Display"/>
+              </a:rPr>
+              <a:t>Conclusiones</a:t>
+            </a:r>
+          </a:p>
+          <a:p>
+            <a:pPr marL="939494" lvl="1" indent="-469747" algn="l">
+              <a:lnSpc>
+                <a:spcPct val="150000"/>
+              </a:lnSpc>
+              <a:buAutoNum type="arabicPeriod" startAt="7"/>
+            </a:pPr>
+            <a:r>
+              <a:rPr lang="es-ES" sz="1600" noProof="0" dirty="0">
+                <a:solidFill>
+                  <a:schemeClr val="tx2">
+                    <a:lumMod val="40000"/>
+                    <a:lumOff val="60000"/>
+                  </a:schemeClr>
+                </a:solidFill>
+                <a:latin typeface="Roboto Condensed" panose="02000000000000000000" pitchFamily="2" charset="0"/>
+                <a:ea typeface="Roboto Condensed" panose="02000000000000000000" pitchFamily="2" charset="0"/>
+                <a:cs typeface="Playfair Display"/>
+                <a:sym typeface="Playfair Display"/>
+              </a:rPr>
+              <a:t>Líneas futuras</a:t>
+            </a:r>
+          </a:p>
+        </p:txBody>
+      </p:sp>
     </p:spTree>
     <p:extLst>
       <p:ext uri="{BB962C8B-B14F-4D97-AF65-F5344CB8AC3E}">
@@ -8746,29 +9161,28 @@
         </p:nvSpPr>
         <p:spPr>
           <a:xfrm>
-            <a:off x="10915523" y="4634713"/>
-            <a:ext cx="5456316" cy="3748147"/>
+            <a:off x="10407112" y="2053834"/>
+            <a:ext cx="7195088" cy="7386638"/>
           </a:xfrm>
           <a:prstGeom prst="rect">
             <a:avLst/>
           </a:prstGeom>
         </p:spPr>
         <p:txBody>
-          <a:bodyPr lIns="0" tIns="0" rIns="0" bIns="0" rtlCol="0" anchor="t">
+          <a:bodyPr wrap="square" lIns="0" tIns="0" rIns="0" bIns="0" rtlCol="0" anchor="t">
             <a:spAutoFit/>
           </a:bodyPr>
           <a:lstStyle/>
           <a:p>
-            <a:pPr algn="l">
-              <a:lnSpc>
-                <a:spcPts val="6001"/>
-              </a:lnSpc>
+            <a:pPr marL="571500" indent="-571500" algn="l">
               <a:spcBef>
                 <a:spcPct val="0"/>
               </a:spcBef>
-            </a:pPr>
-            <a:r>
-              <a:rPr lang="es-ES" sz="4286" noProof="0" dirty="0">
+              <a:buFont typeface="Arial" panose="020B0604020202020204" pitchFamily="34" charset="0"/>
+              <a:buChar char="•"/>
+            </a:pPr>
+            <a:r>
+              <a:rPr lang="es-ES" sz="3200" noProof="0" dirty="0">
                 <a:solidFill>
                   <a:srgbClr val="1A2161"/>
                 </a:solidFill>
@@ -8777,7 +9191,130 @@
                 <a:cs typeface="Open Sans"/>
                 <a:sym typeface="Open Sans"/>
               </a:rPr>
-              <a:t>del tiempo en un proyecto creativo se dedica a la fase de exploración e ideación.</a:t>
+              <a:t>Entorno RL completo desarrollado en CoppeliaSim + Python + PPO.</a:t>
+            </a:r>
+          </a:p>
+          <a:p>
+            <a:pPr algn="l">
+              <a:spcBef>
+                <a:spcPct val="0"/>
+              </a:spcBef>
+            </a:pPr>
+            <a:endParaRPr lang="es-ES" sz="3200" noProof="0" dirty="0">
+              <a:solidFill>
+                <a:srgbClr val="1A2161"/>
+              </a:solidFill>
+              <a:latin typeface="Open Sans"/>
+              <a:ea typeface="Open Sans"/>
+              <a:cs typeface="Open Sans"/>
+              <a:sym typeface="Open Sans"/>
+            </a:endParaRPr>
+          </a:p>
+          <a:p>
+            <a:pPr marL="571500" indent="-571500" algn="l">
+              <a:spcBef>
+                <a:spcPct val="0"/>
+              </a:spcBef>
+              <a:buFont typeface="Arial" panose="020B0604020202020204" pitchFamily="34" charset="0"/>
+              <a:buChar char="•"/>
+            </a:pPr>
+            <a:r>
+              <a:rPr lang="es-ES" sz="3200" noProof="0" dirty="0">
+                <a:solidFill>
+                  <a:srgbClr val="1A2161"/>
+                </a:solidFill>
+                <a:latin typeface="Open Sans"/>
+                <a:ea typeface="Open Sans"/>
+                <a:cs typeface="Open Sans"/>
+                <a:sym typeface="Open Sans"/>
+              </a:rPr>
+              <a:t>Las recompensas densas superaron claramente a las recompensas dispersas.</a:t>
+            </a:r>
+          </a:p>
+          <a:p>
+            <a:pPr algn="l">
+              <a:spcBef>
+                <a:spcPct val="0"/>
+              </a:spcBef>
+            </a:pPr>
+            <a:endParaRPr lang="es-ES" sz="3200" noProof="0" dirty="0">
+              <a:solidFill>
+                <a:srgbClr val="1A2161"/>
+              </a:solidFill>
+              <a:latin typeface="Open Sans"/>
+              <a:ea typeface="Open Sans"/>
+              <a:cs typeface="Open Sans"/>
+              <a:sym typeface="Open Sans"/>
+            </a:endParaRPr>
+          </a:p>
+          <a:p>
+            <a:pPr marL="571500" indent="-571500" algn="l">
+              <a:spcBef>
+                <a:spcPct val="0"/>
+              </a:spcBef>
+              <a:buFont typeface="Arial" panose="020B0604020202020204" pitchFamily="34" charset="0"/>
+              <a:buChar char="•"/>
+            </a:pPr>
+            <a:r>
+              <a:rPr lang="es-ES" sz="3200" dirty="0">
+                <a:solidFill>
+                  <a:srgbClr val="1A2161"/>
+                </a:solidFill>
+                <a:latin typeface="Open Sans"/>
+                <a:ea typeface="Open Sans"/>
+                <a:cs typeface="Open Sans"/>
+                <a:sym typeface="Open Sans"/>
+              </a:rPr>
+              <a:t>E</a:t>
+            </a:r>
+            <a:r>
+              <a:rPr lang="es-ES" sz="3200" noProof="0" dirty="0">
+                <a:solidFill>
+                  <a:srgbClr val="1A2161"/>
+                </a:solidFill>
+                <a:latin typeface="Open Sans"/>
+                <a:ea typeface="Open Sans"/>
+                <a:cs typeface="Open Sans"/>
+                <a:sym typeface="Open Sans"/>
+              </a:rPr>
+              <a:t>xp_006 obtuvo el mejor equilibrio global: cobertura, energía y balance.</a:t>
+            </a:r>
+          </a:p>
+          <a:p>
+            <a:pPr algn="l">
+              <a:spcBef>
+                <a:spcPct val="0"/>
+              </a:spcBef>
+            </a:pPr>
+            <a:endParaRPr lang="es-ES" sz="3200" noProof="0" dirty="0">
+              <a:solidFill>
+                <a:srgbClr val="1A2161"/>
+              </a:solidFill>
+              <a:latin typeface="Open Sans"/>
+              <a:ea typeface="Open Sans"/>
+              <a:cs typeface="Open Sans"/>
+              <a:sym typeface="Open Sans"/>
+            </a:endParaRPr>
+          </a:p>
+          <a:p>
+            <a:pPr marL="571500" indent="-571500" algn="l">
+              <a:spcBef>
+                <a:spcPct val="0"/>
+              </a:spcBef>
+              <a:buFont typeface="Arial" panose="020B0604020202020204" pitchFamily="34" charset="0"/>
+              <a:buChar char="•"/>
+            </a:pPr>
+            <a:r>
+              <a:rPr lang="es-ES" sz="3200" noProof="0" dirty="0">
+                <a:solidFill>
+                  <a:srgbClr val="1A2161"/>
+                </a:solidFill>
+                <a:latin typeface="Open Sans"/>
+                <a:ea typeface="Open Sans"/>
+                <a:cs typeface="Open Sans"/>
+                <a:sym typeface="Open Sans"/>
+              </a:rPr>
+              <a:t>La información temporal modificó la estrategia energética, pero no resolvió el desequilibrio entre habitaciones.</a:t>
             </a:r>
           </a:p>
         </p:txBody>
@@ -8856,50 +9393,6 @@
               <a:cs typeface="Playfair Display"/>
               <a:sym typeface="Playfair Display"/>
             </a:endParaRPr>
-          </a:p>
-        </p:txBody>
-      </p:sp>
-      <p:sp>
-        <p:nvSpPr>
-          <p:cNvPr id="13" name="TextBox 13"/>
-          <p:cNvSpPr txBox="1"/>
-          <p:nvPr/>
-        </p:nvSpPr>
-        <p:spPr>
-          <a:xfrm>
-            <a:off x="10621241" y="1720764"/>
-            <a:ext cx="5365615" cy="2999674"/>
-          </a:xfrm>
-          <a:prstGeom prst="rect">
-            <a:avLst/>
-          </a:prstGeom>
-        </p:spPr>
-        <p:txBody>
-          <a:bodyPr lIns="0" tIns="0" rIns="0" bIns="0" rtlCol="0" anchor="t">
-            <a:spAutoFit/>
-          </a:bodyPr>
-          <a:lstStyle/>
-          <a:p>
-            <a:pPr algn="ctr">
-              <a:lnSpc>
-                <a:spcPts val="24941"/>
-              </a:lnSpc>
-              <a:spcBef>
-                <a:spcPct val="0"/>
-              </a:spcBef>
-            </a:pPr>
-            <a:r>
-              <a:rPr lang="es-ES" sz="17815" b="1" noProof="0" dirty="0">
-                <a:solidFill>
-                  <a:srgbClr val="1A2161"/>
-                </a:solidFill>
-                <a:latin typeface="Open Sans Bold"/>
-                <a:ea typeface="Open Sans Bold"/>
-                <a:cs typeface="Open Sans Bold"/>
-                <a:sym typeface="Open Sans Bold"/>
-              </a:rPr>
-              <a:t>30%</a:t>
-            </a:r>
           </a:p>
         </p:txBody>
       </p:sp>
@@ -9327,94 +9820,6 @@
       </p:sp>
       <p:sp>
         <p:nvSpPr>
-          <p:cNvPr id="12" name="TextBox 12"/>
-          <p:cNvSpPr txBox="1"/>
-          <p:nvPr/>
-        </p:nvSpPr>
-        <p:spPr>
-          <a:xfrm>
-            <a:off x="10621241" y="1720764"/>
-            <a:ext cx="5365615" cy="2999674"/>
-          </a:xfrm>
-          <a:prstGeom prst="rect">
-            <a:avLst/>
-          </a:prstGeom>
-        </p:spPr>
-        <p:txBody>
-          <a:bodyPr lIns="0" tIns="0" rIns="0" bIns="0" rtlCol="0" anchor="t">
-            <a:spAutoFit/>
-          </a:bodyPr>
-          <a:lstStyle/>
-          <a:p>
-            <a:pPr algn="ctr">
-              <a:lnSpc>
-                <a:spcPts val="24941"/>
-              </a:lnSpc>
-              <a:spcBef>
-                <a:spcPct val="0"/>
-              </a:spcBef>
-            </a:pPr>
-            <a:r>
-              <a:rPr lang="es-ES" sz="17815" b="1" noProof="0" dirty="0">
-                <a:solidFill>
-                  <a:srgbClr val="1A2161"/>
-                </a:solidFill>
-                <a:latin typeface="Open Sans Bold"/>
-                <a:ea typeface="Open Sans Bold"/>
-                <a:cs typeface="Open Sans Bold"/>
-                <a:sym typeface="Open Sans Bold"/>
-              </a:rPr>
-              <a:t>17%</a:t>
-            </a:r>
-          </a:p>
-        </p:txBody>
-      </p:sp>
-      <p:sp>
-        <p:nvSpPr>
-          <p:cNvPr id="13" name="TextBox 13"/>
-          <p:cNvSpPr txBox="1"/>
-          <p:nvPr/>
-        </p:nvSpPr>
-        <p:spPr>
-          <a:xfrm>
-            <a:off x="11133842" y="4634713"/>
-            <a:ext cx="5456316" cy="3748147"/>
-          </a:xfrm>
-          <a:prstGeom prst="rect">
-            <a:avLst/>
-          </a:prstGeom>
-        </p:spPr>
-        <p:txBody>
-          <a:bodyPr lIns="0" tIns="0" rIns="0" bIns="0" rtlCol="0" anchor="t">
-            <a:spAutoFit/>
-          </a:bodyPr>
-          <a:lstStyle/>
-          <a:p>
-            <a:pPr algn="l">
-              <a:lnSpc>
-                <a:spcPts val="6001"/>
-              </a:lnSpc>
-              <a:spcBef>
-                <a:spcPct val="0"/>
-              </a:spcBef>
-            </a:pPr>
-            <a:r>
-              <a:rPr lang="es-ES" sz="4286" noProof="0" dirty="0">
-                <a:solidFill>
-                  <a:srgbClr val="1A2161"/>
-                </a:solidFill>
-                <a:latin typeface="Open Sans"/>
-                <a:ea typeface="Open Sans"/>
-                <a:cs typeface="Open Sans"/>
-                <a:sym typeface="Open Sans"/>
-              </a:rPr>
-              <a:t>de las ideas generadas en una sesión creativa llegan a convertirse en un proyecto real</a:t>
-            </a:r>
-          </a:p>
-        </p:txBody>
-      </p:sp>
-      <p:sp>
-        <p:nvSpPr>
           <p:cNvPr id="15" name="TextBox 9">
             <a:extLst>
               <a:ext uri="{FF2B5EF4-FFF2-40B4-BE49-F238E27FC236}">
@@ -9573,6 +9978,375 @@
                 <a:sym typeface="Playfair Display"/>
               </a:rPr>
               <a:t>Líneas futuras</a:t>
+            </a:r>
+          </a:p>
+        </p:txBody>
+      </p:sp>
+      <p:sp>
+        <p:nvSpPr>
+          <p:cNvPr id="7" name="TextBox 11">
+            <a:extLst>
+              <a:ext uri="{FF2B5EF4-FFF2-40B4-BE49-F238E27FC236}">
+                <a16:creationId xmlns:a16="http://schemas.microsoft.com/office/drawing/2014/main" id="{045BF988-3DD9-DF94-454F-A764E66BA7E4}"/>
+              </a:ext>
+            </a:extLst>
+          </p:cNvPr>
+          <p:cNvSpPr txBox="1"/>
+          <p:nvPr/>
+        </p:nvSpPr>
+        <p:spPr>
+          <a:xfrm>
+            <a:off x="10415636" y="2196644"/>
+            <a:ext cx="7195088" cy="1969770"/>
+          </a:xfrm>
+          <a:prstGeom prst="rect">
+            <a:avLst/>
+          </a:prstGeom>
+        </p:spPr>
+        <p:txBody>
+          <a:bodyPr wrap="square" lIns="0" tIns="0" rIns="0" bIns="0" rtlCol="0" anchor="t">
+            <a:spAutoFit/>
+          </a:bodyPr>
+          <a:lstStyle/>
+          <a:p>
+            <a:pPr algn="l">
+              <a:spcBef>
+                <a:spcPct val="0"/>
+              </a:spcBef>
+            </a:pPr>
+            <a:r>
+              <a:rPr lang="es-ES" sz="3200" b="1" noProof="0" dirty="0">
+                <a:solidFill>
+                  <a:schemeClr val="bg1"/>
+                </a:solidFill>
+                <a:latin typeface="Open Sans"/>
+                <a:ea typeface="Open Sans"/>
+                <a:cs typeface="Open Sans"/>
+                <a:sym typeface="Open Sans"/>
+              </a:rPr>
+              <a:t>Complejidad del entorno</a:t>
+            </a:r>
+          </a:p>
+          <a:p>
+            <a:pPr marL="1028700" lvl="1" indent="-571500">
+              <a:spcBef>
+                <a:spcPct val="0"/>
+              </a:spcBef>
+              <a:buFont typeface="Arial" panose="020B0604020202020204" pitchFamily="34" charset="0"/>
+              <a:buChar char="•"/>
+            </a:pPr>
+            <a:r>
+              <a:rPr lang="es-ES" sz="3200" noProof="0" dirty="0">
+                <a:solidFill>
+                  <a:schemeClr val="bg1"/>
+                </a:solidFill>
+                <a:latin typeface="Open Sans"/>
+                <a:ea typeface="Open Sans"/>
+                <a:cs typeface="Open Sans"/>
+                <a:sym typeface="Open Sans"/>
+              </a:rPr>
+              <a:t>Más habitaciones.</a:t>
+            </a:r>
+          </a:p>
+          <a:p>
+            <a:pPr marL="1028700" lvl="1" indent="-571500">
+              <a:spcBef>
+                <a:spcPct val="0"/>
+              </a:spcBef>
+              <a:buFont typeface="Arial" panose="020B0604020202020204" pitchFamily="34" charset="0"/>
+              <a:buChar char="•"/>
+            </a:pPr>
+            <a:r>
+              <a:rPr lang="es-ES" sz="3200" noProof="0" dirty="0">
+                <a:solidFill>
+                  <a:schemeClr val="bg1"/>
+                </a:solidFill>
+                <a:latin typeface="Open Sans"/>
+                <a:ea typeface="Open Sans"/>
+                <a:cs typeface="Open Sans"/>
+                <a:sym typeface="Open Sans"/>
+              </a:rPr>
+              <a:t>Obstáculos dinámicos.</a:t>
+            </a:r>
+          </a:p>
+          <a:p>
+            <a:pPr marL="1028700" lvl="1" indent="-571500">
+              <a:spcBef>
+                <a:spcPct val="0"/>
+              </a:spcBef>
+              <a:buFont typeface="Arial" panose="020B0604020202020204" pitchFamily="34" charset="0"/>
+              <a:buChar char="•"/>
+            </a:pPr>
+            <a:r>
+              <a:rPr lang="es-ES" sz="3200" noProof="0" dirty="0">
+                <a:solidFill>
+                  <a:schemeClr val="bg1"/>
+                </a:solidFill>
+                <a:latin typeface="Open Sans"/>
+                <a:ea typeface="Open Sans"/>
+                <a:cs typeface="Open Sans"/>
+                <a:sym typeface="Open Sans"/>
+              </a:rPr>
+              <a:t>Varias estaciones de carga.</a:t>
+            </a:r>
+          </a:p>
+        </p:txBody>
+      </p:sp>
+      <p:sp>
+        <p:nvSpPr>
+          <p:cNvPr id="9" name="TextBox 11">
+            <a:extLst>
+              <a:ext uri="{FF2B5EF4-FFF2-40B4-BE49-F238E27FC236}">
+                <a16:creationId xmlns:a16="http://schemas.microsoft.com/office/drawing/2014/main" id="{98D710BF-AA18-299A-EA73-711ED084A867}"/>
+              </a:ext>
+            </a:extLst>
+          </p:cNvPr>
+          <p:cNvSpPr txBox="1"/>
+          <p:nvPr/>
+        </p:nvSpPr>
+        <p:spPr>
+          <a:xfrm>
+            <a:off x="10415636" y="4610100"/>
+            <a:ext cx="7195088" cy="1969770"/>
+          </a:xfrm>
+          <a:prstGeom prst="rect">
+            <a:avLst/>
+          </a:prstGeom>
+        </p:spPr>
+        <p:txBody>
+          <a:bodyPr wrap="square" lIns="0" tIns="0" rIns="0" bIns="0" rtlCol="0" anchor="t">
+            <a:spAutoFit/>
+          </a:bodyPr>
+          <a:lstStyle/>
+          <a:p>
+            <a:pPr algn="l">
+              <a:spcBef>
+                <a:spcPct val="0"/>
+              </a:spcBef>
+            </a:pPr>
+            <a:r>
+              <a:rPr lang="es-ES" sz="3200" b="1" noProof="0" dirty="0">
+                <a:solidFill>
+                  <a:schemeClr val="bg1"/>
+                </a:solidFill>
+                <a:latin typeface="Open Sans"/>
+                <a:ea typeface="Open Sans"/>
+                <a:cs typeface="Open Sans"/>
+                <a:sym typeface="Open Sans"/>
+              </a:rPr>
+              <a:t>Mejoras en RL</a:t>
+            </a:r>
+          </a:p>
+          <a:p>
+            <a:pPr marL="914400" lvl="1" indent="-457200">
+              <a:spcBef>
+                <a:spcPct val="0"/>
+              </a:spcBef>
+              <a:buFont typeface="Arial" panose="020B0604020202020204" pitchFamily="34" charset="0"/>
+              <a:buChar char="•"/>
+            </a:pPr>
+            <a:r>
+              <a:rPr lang="es-ES" sz="3200" noProof="0" dirty="0">
+                <a:solidFill>
+                  <a:schemeClr val="bg1"/>
+                </a:solidFill>
+                <a:latin typeface="Open Sans"/>
+                <a:ea typeface="Open Sans"/>
+                <a:cs typeface="Open Sans"/>
+                <a:sym typeface="Open Sans"/>
+              </a:rPr>
+              <a:t>Algoritmos alternativos a PPO.</a:t>
+            </a:r>
+          </a:p>
+          <a:p>
+            <a:pPr marL="914400" lvl="1" indent="-457200">
+              <a:spcBef>
+                <a:spcPct val="0"/>
+              </a:spcBef>
+              <a:buFont typeface="Arial" panose="020B0604020202020204" pitchFamily="34" charset="0"/>
+              <a:buChar char="•"/>
+            </a:pPr>
+            <a:r>
+              <a:rPr lang="es-ES" sz="3200" noProof="0" dirty="0">
+                <a:solidFill>
+                  <a:schemeClr val="bg1"/>
+                </a:solidFill>
+                <a:latin typeface="Open Sans"/>
+                <a:ea typeface="Open Sans"/>
+                <a:cs typeface="Open Sans"/>
+                <a:sym typeface="Open Sans"/>
+              </a:rPr>
+              <a:t>Memoria temporal.</a:t>
+            </a:r>
+          </a:p>
+          <a:p>
+            <a:pPr marL="914400" lvl="1" indent="-457200">
+              <a:spcBef>
+                <a:spcPct val="0"/>
+              </a:spcBef>
+              <a:buFont typeface="Arial" panose="020B0604020202020204" pitchFamily="34" charset="0"/>
+              <a:buChar char="•"/>
+            </a:pPr>
+            <a:r>
+              <a:rPr lang="es-ES" sz="3200" noProof="0" dirty="0" err="1">
+                <a:solidFill>
+                  <a:schemeClr val="bg1"/>
+                </a:solidFill>
+                <a:latin typeface="Open Sans"/>
+                <a:ea typeface="Open Sans"/>
+                <a:cs typeface="Open Sans"/>
+                <a:sym typeface="Open Sans"/>
+              </a:rPr>
+              <a:t>Reward</a:t>
+            </a:r>
+            <a:r>
+              <a:rPr lang="es-ES" sz="3200" noProof="0" dirty="0">
+                <a:solidFill>
+                  <a:schemeClr val="bg1"/>
+                </a:solidFill>
+                <a:latin typeface="Open Sans"/>
+                <a:ea typeface="Open Sans"/>
+                <a:cs typeface="Open Sans"/>
+                <a:sym typeface="Open Sans"/>
+              </a:rPr>
+              <a:t> </a:t>
+            </a:r>
+            <a:r>
+              <a:rPr lang="es-ES" sz="3200" noProof="0" dirty="0" err="1">
+                <a:solidFill>
+                  <a:schemeClr val="bg1"/>
+                </a:solidFill>
+                <a:latin typeface="Open Sans"/>
+                <a:ea typeface="Open Sans"/>
+                <a:cs typeface="Open Sans"/>
+                <a:sym typeface="Open Sans"/>
+              </a:rPr>
+              <a:t>shaping</a:t>
+            </a:r>
+            <a:r>
+              <a:rPr lang="es-ES" sz="3200" noProof="0" dirty="0">
+                <a:solidFill>
+                  <a:schemeClr val="bg1"/>
+                </a:solidFill>
+                <a:latin typeface="Open Sans"/>
+                <a:ea typeface="Open Sans"/>
+                <a:cs typeface="Open Sans"/>
+                <a:sym typeface="Open Sans"/>
+              </a:rPr>
+              <a:t> multiobjetivo.</a:t>
+            </a:r>
+          </a:p>
+        </p:txBody>
+      </p:sp>
+      <p:sp>
+        <p:nvSpPr>
+          <p:cNvPr id="16" name="TextBox 11">
+            <a:extLst>
+              <a:ext uri="{FF2B5EF4-FFF2-40B4-BE49-F238E27FC236}">
+                <a16:creationId xmlns:a16="http://schemas.microsoft.com/office/drawing/2014/main" id="{B478E624-EBD5-7BBC-7CE7-ED5605F3157E}"/>
+              </a:ext>
+            </a:extLst>
+          </p:cNvPr>
+          <p:cNvSpPr txBox="1"/>
+          <p:nvPr/>
+        </p:nvSpPr>
+        <p:spPr>
+          <a:xfrm>
+            <a:off x="10415636" y="7105471"/>
+            <a:ext cx="7195088" cy="1477328"/>
+          </a:xfrm>
+          <a:prstGeom prst="rect">
+            <a:avLst/>
+          </a:prstGeom>
+        </p:spPr>
+        <p:txBody>
+          <a:bodyPr wrap="square" lIns="0" tIns="0" rIns="0" bIns="0" rtlCol="0" anchor="t">
+            <a:spAutoFit/>
+          </a:bodyPr>
+          <a:lstStyle/>
+          <a:p>
+            <a:pPr algn="l">
+              <a:spcBef>
+                <a:spcPct val="0"/>
+              </a:spcBef>
+            </a:pPr>
+            <a:r>
+              <a:rPr lang="es-ES" sz="3200" b="1" noProof="0" dirty="0">
+                <a:solidFill>
+                  <a:schemeClr val="bg1"/>
+                </a:solidFill>
+                <a:latin typeface="Open Sans"/>
+                <a:ea typeface="Open Sans"/>
+                <a:cs typeface="Open Sans"/>
+                <a:sym typeface="Open Sans"/>
+              </a:rPr>
+              <a:t>Escalado del sistema</a:t>
+            </a:r>
+          </a:p>
+          <a:p>
+            <a:pPr marL="914400" lvl="1" indent="-457200">
+              <a:spcBef>
+                <a:spcPct val="0"/>
+              </a:spcBef>
+              <a:buFont typeface="Arial" panose="020B0604020202020204" pitchFamily="34" charset="0"/>
+              <a:buChar char="•"/>
+            </a:pPr>
+            <a:r>
+              <a:rPr lang="es-ES" sz="3200" noProof="0" dirty="0">
+                <a:solidFill>
+                  <a:schemeClr val="bg1"/>
+                </a:solidFill>
+                <a:latin typeface="Open Sans"/>
+                <a:ea typeface="Open Sans"/>
+                <a:cs typeface="Open Sans"/>
+                <a:sym typeface="Open Sans"/>
+              </a:rPr>
+              <a:t>Transferencia a robot real.</a:t>
+            </a:r>
+          </a:p>
+          <a:p>
+            <a:pPr marL="914400" lvl="1" indent="-457200">
+              <a:spcBef>
+                <a:spcPct val="0"/>
+              </a:spcBef>
+              <a:buFont typeface="Arial" panose="020B0604020202020204" pitchFamily="34" charset="0"/>
+              <a:buChar char="•"/>
+            </a:pPr>
+            <a:r>
+              <a:rPr lang="es-ES" sz="3200" noProof="0" dirty="0">
+                <a:solidFill>
+                  <a:schemeClr val="bg1"/>
+                </a:solidFill>
+                <a:latin typeface="Open Sans"/>
+                <a:ea typeface="Open Sans"/>
+                <a:cs typeface="Open Sans"/>
+                <a:sym typeface="Open Sans"/>
+              </a:rPr>
+              <a:t>Patrullaje </a:t>
+            </a:r>
+            <a:r>
+              <a:rPr lang="es-ES" sz="3200" noProof="0" dirty="0" err="1">
+                <a:solidFill>
+                  <a:schemeClr val="bg1"/>
+                </a:solidFill>
+                <a:latin typeface="Open Sans"/>
+                <a:ea typeface="Open Sans"/>
+                <a:cs typeface="Open Sans"/>
+                <a:sym typeface="Open Sans"/>
+              </a:rPr>
+              <a:t>multiagente</a:t>
+            </a:r>
+            <a:r>
+              <a:rPr lang="es-ES" sz="3200" noProof="0" dirty="0">
+                <a:solidFill>
+                  <a:schemeClr val="bg1"/>
+                </a:solidFill>
+                <a:latin typeface="Open Sans"/>
+                <a:ea typeface="Open Sans"/>
+                <a:cs typeface="Open Sans"/>
+                <a:sym typeface="Open Sans"/>
+              </a:rPr>
+              <a:t>.</a:t>
             </a:r>
           </a:p>
         </p:txBody>
@@ -12723,7 +13497,7 @@
             </a:pathLst>
           </a:custGeom>
           <a:blipFill>
-            <a:blip r:embed="rId2"/>
+            <a:blip r:embed="rId3"/>
             <a:stretch>
               <a:fillRect/>
             </a:stretch>
@@ -12782,7 +13556,7 @@
             </a:pathLst>
           </a:custGeom>
           <a:blipFill>
-            <a:blip r:embed="rId2"/>
+            <a:blip r:embed="rId3"/>
             <a:stretch>
               <a:fillRect/>
             </a:stretch>
@@ -13139,14 +13913,14 @@
           <p:nvPr/>
         </p:nvPicPr>
         <p:blipFill>
-          <a:blip r:embed="rId3"/>
+          <a:blip r:embed="rId4"/>
           <a:stretch>
             <a:fillRect/>
           </a:stretch>
         </p:blipFill>
         <p:spPr>
           <a:xfrm>
-            <a:off x="7548001" y="4436253"/>
+            <a:off x="6786591" y="3568033"/>
             <a:ext cx="2887196" cy="1624048"/>
           </a:xfrm>
           <a:prstGeom prst="rect">
@@ -13169,14 +13943,14 @@
           <p:nvPr/>
         </p:nvPicPr>
         <p:blipFill>
-          <a:blip r:embed="rId4"/>
+          <a:blip r:embed="rId5"/>
           <a:stretch>
             <a:fillRect/>
           </a:stretch>
         </p:blipFill>
         <p:spPr>
           <a:xfrm>
-            <a:off x="5043234" y="7435130"/>
+            <a:off x="15011400" y="5128585"/>
             <a:ext cx="1715975" cy="1624048"/>
           </a:xfrm>
           <a:prstGeom prst="rect">
@@ -13199,14 +13973,14 @@
           <p:nvPr/>
         </p:nvPicPr>
         <p:blipFill>
-          <a:blip r:embed="rId5"/>
+          <a:blip r:embed="rId6"/>
           <a:stretch>
             <a:fillRect/>
           </a:stretch>
         </p:blipFill>
         <p:spPr>
           <a:xfrm>
-            <a:off x="9568706" y="6694893"/>
+            <a:off x="3289782" y="3423941"/>
             <a:ext cx="1409700" cy="1409700"/>
           </a:xfrm>
           <a:prstGeom prst="rect">
@@ -13232,7 +14006,7 @@
           <a:blip>
             <a:extLst>
               <a:ext uri="{96DAC541-7B7A-43D3-8B79-37D633B846F1}">
-                <asvg:svgBlip xmlns:asvg="http://schemas.microsoft.com/office/drawing/2016/SVG/main" r:embed="rId6"/>
+                <asvg:svgBlip xmlns:asvg="http://schemas.microsoft.com/office/drawing/2016/SVG/main" r:embed="rId7"/>
               </a:ext>
             </a:extLst>
           </a:blip>
@@ -13242,7 +14016,7 @@
         </p:blipFill>
         <p:spPr>
           <a:xfrm>
-            <a:off x="4460377" y="4108976"/>
+            <a:off x="4252765" y="5307876"/>
             <a:ext cx="1715975" cy="1715975"/>
           </a:xfrm>
           <a:prstGeom prst="rect">
@@ -13265,14 +14039,14 @@
           <p:nvPr/>
         </p:nvPicPr>
         <p:blipFill>
-          <a:blip r:embed="rId7"/>
+          <a:blip r:embed="rId8"/>
           <a:stretch>
             <a:fillRect/>
           </a:stretch>
         </p:blipFill>
         <p:spPr>
           <a:xfrm>
-            <a:off x="3352800" y="2577005"/>
+            <a:off x="8267633" y="5105017"/>
             <a:ext cx="1524000" cy="1524000"/>
           </a:xfrm>
           <a:prstGeom prst="rect">
@@ -13295,14 +14069,14 @@
           <p:nvPr/>
         </p:nvPicPr>
         <p:blipFill>
-          <a:blip r:embed="rId8"/>
+          <a:blip r:embed="rId9"/>
           <a:stretch>
             <a:fillRect/>
           </a:stretch>
         </p:blipFill>
         <p:spPr>
           <a:xfrm>
-            <a:off x="12416127" y="3684394"/>
+            <a:off x="11549495" y="4511058"/>
             <a:ext cx="2702297" cy="2355736"/>
           </a:xfrm>
           <a:prstGeom prst="rect">
@@ -13325,14 +14099,14 @@
           <p:nvPr/>
         </p:nvPicPr>
         <p:blipFill>
-          <a:blip r:embed="rId9"/>
+          <a:blip r:embed="rId10"/>
           <a:stretch>
             <a:fillRect/>
           </a:stretch>
         </p:blipFill>
         <p:spPr>
           <a:xfrm>
-            <a:off x="12212515" y="2764736"/>
+            <a:off x="12900643" y="3416261"/>
             <a:ext cx="3109520" cy="767602"/>
           </a:xfrm>
           <a:prstGeom prst="rect">
@@ -13355,14 +14129,14 @@
           <p:nvPr/>
         </p:nvPicPr>
         <p:blipFill>
-          <a:blip r:embed="rId10"/>
+          <a:blip r:embed="rId11"/>
           <a:stretch>
             <a:fillRect/>
           </a:stretch>
         </p:blipFill>
         <p:spPr>
           <a:xfrm>
-            <a:off x="14097000" y="8294463"/>
+            <a:off x="2630737" y="5246985"/>
             <a:ext cx="1572874" cy="1572874"/>
           </a:xfrm>
           <a:prstGeom prst="rect">

</xml_diff>